<commit_message>
docs(pptx): actualizar Metodología.pptx con rangos nuevos 0-30/31-60/61-100
Nadia actualizó los 3 textos de rangos de factibilidad en las slides
para que matcheen con los rangos aplicados en el código y la BD.
Diff textual: solo cambian las 3 líneas de rangos, los 97 bloques
de texto restantes son idénticos.

Co-Authored-By: Claude Opus 4.7 (1M context) <noreply@anthropic.com>
</commit_message>
<xml_diff>
--- a/pdf/Metodologia.pptx
+++ b/pdf/Metodologia.pptx
@@ -6519,7 +6519,7 @@
                   <a:schemeClr val="accent6"/>
                 </a:solidFill>
               </a:rPr>
-              <a:t>0 a 20 – Factibilidad a largo plazo</a:t>
+              <a:t>0 a 30 Factibilidad a largo plazo</a:t>
             </a:r>
           </a:p>
           <a:p>
@@ -6536,7 +6536,7 @@
                   <a:schemeClr val="accent6"/>
                 </a:solidFill>
               </a:rPr>
-              <a:t>21 a 65 - Factibilidad a mediano plazo</a:t>
+              <a:t>31 a 60 - Factibilidad a mediano plazo</a:t>
             </a:r>
           </a:p>
           <a:p>
@@ -6548,12 +6548,20 @@
               <a:buNone/>
             </a:pPr>
             <a:r>
+              <a:rPr lang="es-ES" sz="800">
+                <a:solidFill>
+                  <a:schemeClr val="accent6"/>
+                </a:solidFill>
+              </a:rPr>
+              <a:t>61 </a:t>
+            </a:r>
+            <a:r>
               <a:rPr lang="es-ES" sz="800" dirty="0">
                 <a:solidFill>
                   <a:schemeClr val="accent6"/>
                 </a:solidFill>
               </a:rPr>
-              <a:t>66 a 100 - Factibilidad a corto plazo</a:t>
+              <a:t>a 100 - Factibilidad a corto plazo</a:t>
             </a:r>
           </a:p>
           <a:p>

</xml_diff>